<commit_message>
Make go-to-market draft visual to match other drafts
Replace bullet text with icon flows in the 01/02/03 card style used by the
other draft slides, add a loop arrow back to step 1, and show pilot pass
targets as an icon band. Details move to the speaker notes.

Co-Authored-By: Claude Opus 5.5 <noreply@anthropic.com>
Claude-Session: https://claude.ai/code/session_01MF4S689Cu66DaEpymoVfar
</commit_message>
<xml_diff>
--- a/output/drafts/Rentify_v6_slide10_go-to-market.pptx
+++ b/output/drafts/Rentify_v6_slide10_go-to-market.pptx
@@ -504,7 +504,7 @@
               <a:rPr lang="en-US" dirty="0"/>
               <a:t>[3:20–3:45]
 How do we start a marketplace with no buyers? Merchants first. This quarter we sign ten pilot shops in Phnom Penh through market visits, Facebook seller groups and UniPreneur introductions. They join for the tools. Each shop then shares its Rentify link with its own customers, who become our first buyers. On the marketplace, those buyers discover other shops, and that brings more shops in. The pilot passes if seven of ten shops stay active, stock stays 99% accurate, and six of ten will pay.
-(Q&amp;A: targets are proposals agreed before the pilot. We count marketplace-discovered orders separately from each shop's own customers, because only those earn commission.)</a:t>
+(Q&amp;A: targets are proposals agreed before the pilot. We count marketplace-discovered orders separately from each shop's own customers, because only those earn commission. Later growth channels: festival campaigns, SME associations, delivery partners, referral credit.)</a:t>
             </a:r>
             <a:endParaRPr lang="en-US" dirty="0"/>
           </a:p>
@@ -918,57 +918,18 @@
       </p:sp>
       <p:sp>
         <p:nvSpPr>
-          <p:cNvPr id="3" name="Text 1"/>
-          <p:cNvSpPr txBox="1"/>
-          <p:nvPr/>
-        </p:nvSpPr>
-        <p:spPr>
-          <a:xfrm>
-            <a:off x="548640" y="932688"/>
-            <a:ext cx="11091672" cy="365760"/>
-          </a:xfrm>
-          <a:prstGeom prst="rect">
-            <a:avLst/>
-          </a:prstGeom>
-          <a:noFill/>
-          <a:ln/>
-        </p:spPr>
-        <p:txBody>
-          <a:bodyPr wrap="square" lIns="0" tIns="0" rIns="0" bIns="0" rtlCol="0" anchor="ctr"/>
-          <a:lstStyle/>
-          <a:p>
-            <a:pPr algn="ctr" indent="0" marL="0">
-              <a:buNone/>
-            </a:pPr>
-            <a:r>
-              <a:rPr lang="en-US" sz="1600" dirty="0">
-                <a:solidFill>
-                  <a:srgbClr val="52637A"/>
-                </a:solidFill>
-                <a:latin typeface="Arial" pitchFamily="34" charset="0"/>
-                <a:ea typeface="Arial" pitchFamily="34" charset="-122"/>
-                <a:cs typeface="Arial" pitchFamily="34" charset="-120"/>
-              </a:rPr>
-              <a:t>How we start a marketplace that has no buyers yet</a:t>
-            </a:r>
-            <a:endParaRPr lang="en-US" sz="1600" dirty="0"/>
-          </a:p>
-        </p:txBody>
-      </p:sp>
-      <p:sp>
-        <p:nvSpPr>
-          <p:cNvPr id="4" name="Shape 2"/>
+          <p:cNvPr id="3" name="Shape 1"/>
           <p:cNvSpPr/>
           <p:nvPr/>
         </p:nvSpPr>
         <p:spPr>
           <a:xfrm>
-            <a:off x="472288" y="1554480"/>
-            <a:ext cx="3383280" cy="3246120"/>
+            <a:off x="449428" y="1234440"/>
+            <a:ext cx="3429000" cy="3749040"/>
           </a:xfrm>
           <a:prstGeom prst="roundRect">
             <a:avLst>
-              <a:gd name="adj" fmla="val 5634"/>
+              <a:gd name="adj" fmla="val 5333"/>
             </a:avLst>
           </a:prstGeom>
           <a:solidFill>
@@ -983,7 +944,7 @@
           <a:effectLst>
             <a:outerShdw sx="100000" sy="100000" kx="0" ky="0" algn="bl" rotWithShape="0" blurRad="101600" dist="38100" dir="5400000">
               <a:srgbClr val="1A2A4A">
-                <a:alpha val="12000"/>
+                <a:alpha val="14000"/>
               </a:srgbClr>
             </a:outerShdw>
           </a:effectLst>
@@ -991,60 +952,14 @@
       </p:sp>
       <p:sp>
         <p:nvSpPr>
-          <p:cNvPr id="5" name="Shape 3"/>
-          <p:cNvSpPr/>
-          <p:nvPr/>
-        </p:nvSpPr>
-        <p:spPr>
-          <a:xfrm>
-            <a:off x="746608" y="1828800"/>
-            <a:ext cx="658368" cy="658368"/>
-          </a:xfrm>
-          <a:prstGeom prst="roundRect">
-            <a:avLst>
-              <a:gd name="adj" fmla="val 22222"/>
-            </a:avLst>
-          </a:prstGeom>
-          <a:solidFill>
-            <a:srgbClr val="0AA7A2"/>
-          </a:solidFill>
-          <a:ln/>
-        </p:spPr>
-      </p:sp>
-      <p:pic>
-        <p:nvPicPr>
-          <p:cNvPr id="6" name="Image 0" descr="preencoded.png">    </p:cNvPr>
-          <p:cNvPicPr>
-            <a:picLocks noChangeAspect="1"/>
-          </p:cNvPicPr>
-          <p:nvPr/>
-        </p:nvPicPr>
-        <p:blipFill>
-          <a:blip r:embed="rId1"/>
-          <a:stretch>
-            <a:fillRect/>
-          </a:stretch>
-        </p:blipFill>
-        <p:spPr>
-          <a:xfrm>
-            <a:off x="892912" y="1975104"/>
-            <a:ext cx="365760" cy="365760"/>
-          </a:xfrm>
-          <a:prstGeom prst="rect">
-            <a:avLst/>
-          </a:prstGeom>
-        </p:spPr>
-      </p:pic>
-      <p:sp>
-        <p:nvSpPr>
-          <p:cNvPr id="7" name="Text 4"/>
+          <p:cNvPr id="4" name="Text 2"/>
           <p:cNvSpPr txBox="1"/>
           <p:nvPr/>
         </p:nvSpPr>
         <p:spPr>
           <a:xfrm>
-            <a:off x="1569568" y="1828800"/>
-            <a:ext cx="2057400" cy="274320"/>
+            <a:off x="723748" y="1463040"/>
+            <a:ext cx="914400" cy="365760"/>
           </a:xfrm>
           <a:prstGeom prst="rect">
             <a:avLst/>
@@ -1060,7 +975,46 @@
               <a:buNone/>
             </a:pPr>
             <a:r>
-              <a:rPr lang="en-US" sz="1050" b="1" spc="100" kern="0" dirty="0">
+              <a:rPr lang="en-US" sz="1400" b="1" spc="200" kern="0" dirty="0">
+                <a:solidFill>
+                  <a:srgbClr val="52637A"/>
+                </a:solidFill>
+                <a:latin typeface="Arial" pitchFamily="34" charset="0"/>
+                <a:ea typeface="Arial" pitchFamily="34" charset="-122"/>
+                <a:cs typeface="Arial" pitchFamily="34" charset="-120"/>
+              </a:rPr>
+              <a:t>01</a:t>
+            </a:r>
+            <a:endParaRPr lang="en-US" sz="1400" dirty="0"/>
+          </a:p>
+        </p:txBody>
+      </p:sp>
+      <p:sp>
+        <p:nvSpPr>
+          <p:cNvPr id="5" name="Text 3"/>
+          <p:cNvSpPr txBox="1"/>
+          <p:nvPr/>
+        </p:nvSpPr>
+        <p:spPr>
+          <a:xfrm>
+            <a:off x="1775308" y="1463040"/>
+            <a:ext cx="1828800" cy="365760"/>
+          </a:xfrm>
+          <a:prstGeom prst="rect">
+            <a:avLst/>
+          </a:prstGeom>
+          <a:noFill/>
+          <a:ln/>
+        </p:spPr>
+        <p:txBody>
+          <a:bodyPr wrap="square" lIns="0" tIns="0" rIns="0" bIns="0" rtlCol="0" anchor="ctr"/>
+          <a:lstStyle/>
+          <a:p>
+            <a:pPr algn="r" indent="0" marL="0">
+              <a:buNone/>
+            </a:pPr>
+            <a:r>
+              <a:rPr lang="en-US" sz="1100" b="1" spc="100" kern="0" dirty="0">
                 <a:solidFill>
                   <a:srgbClr val="0AA7A2"/>
                 </a:solidFill>
@@ -1070,20 +1024,20 @@
               </a:rPr>
               <a:t>NOW · Q4 2026</a:t>
             </a:r>
-            <a:endParaRPr lang="en-US" sz="1050" dirty="0"/>
+            <a:endParaRPr lang="en-US" sz="1100" dirty="0"/>
           </a:p>
         </p:txBody>
       </p:sp>
       <p:sp>
         <p:nvSpPr>
-          <p:cNvPr id="8" name="Text 5"/>
+          <p:cNvPr id="6" name="Text 4"/>
           <p:cNvSpPr txBox="1"/>
           <p:nvPr/>
         </p:nvSpPr>
         <p:spPr>
           <a:xfrm>
-            <a:off x="1569568" y="2084832"/>
-            <a:ext cx="2103120" cy="457200"/>
+            <a:off x="632308" y="3611880"/>
+            <a:ext cx="3063240" cy="457200"/>
           </a:xfrm>
           <a:prstGeom prst="rect">
             <a:avLst/>
@@ -1095,11 +1049,11 @@
           <a:bodyPr wrap="square" lIns="0" tIns="0" rIns="0" bIns="0" rtlCol="0" anchor="ctr"/>
           <a:lstStyle/>
           <a:p>
-            <a:pPr algn="l" indent="0" marL="0">
+            <a:pPr algn="ctr" indent="0" marL="0">
               <a:buNone/>
             </a:pPr>
             <a:r>
-              <a:rPr lang="en-US" sz="1700" b="1" dirty="0">
+              <a:rPr lang="en-US" sz="2000" b="1" dirty="0">
                 <a:solidFill>
                   <a:srgbClr val="15243A"/>
                 </a:solidFill>
@@ -1107,107 +1061,22 @@
                 <a:ea typeface="Arial" pitchFamily="34" charset="-122"/>
                 <a:cs typeface="Arial" pitchFamily="34" charset="-120"/>
               </a:rPr>
-              <a:t>1. We bring merchants</a:t>
-            </a:r>
-            <a:endParaRPr lang="en-US" sz="1700" dirty="0"/>
+              <a:t>We bring shops</a:t>
+            </a:r>
+            <a:endParaRPr lang="en-US" sz="2000" dirty="0"/>
           </a:p>
         </p:txBody>
       </p:sp>
       <p:sp>
         <p:nvSpPr>
-          <p:cNvPr id="9" name="Text 6"/>
+          <p:cNvPr id="7" name="Text 5"/>
           <p:cNvSpPr txBox="1"/>
           <p:nvPr/>
         </p:nvSpPr>
         <p:spPr>
           <a:xfrm>
-            <a:off x="746608" y="2697480"/>
-            <a:ext cx="2880360" cy="1371600"/>
-          </a:xfrm>
-          <a:prstGeom prst="rect">
-            <a:avLst/>
-          </a:prstGeom>
-          <a:noFill/>
-          <a:ln/>
-        </p:spPr>
-        <p:txBody>
-          <a:bodyPr wrap="square" lIns="0" tIns="0" rIns="0" bIns="0" rtlCol="0" anchor="t"/>
-          <a:lstStyle/>
-          <a:p>
-            <a:pPr algn="l" marL="177800" indent="-177800">
-              <a:spcAft>
-                <a:spcPts val="600"/>
-              </a:spcAft>
-              <a:buSzPct val="100000"/>
-              <a:buChar char="•"/>
-            </a:pPr>
-            <a:r>
-              <a:rPr lang="en-US" sz="1300" dirty="0">
-                <a:solidFill>
-                  <a:srgbClr val="15243A"/>
-                </a:solidFill>
-                <a:latin typeface="Arial" pitchFamily="34" charset="0"/>
-                <a:ea typeface="Arial" pitchFamily="34" charset="-122"/>
-                <a:cs typeface="Arial" pitchFamily="34" charset="-120"/>
-              </a:rPr>
-              <a:t>Visit shops in Phnom Penh markets</a:t>
-            </a:r>
-            <a:endParaRPr lang="en-US" sz="1300" dirty="0"/>
-          </a:p>
-          <a:p>
-            <a:pPr algn="l" marL="177800" indent="-177800">
-              <a:spcAft>
-                <a:spcPts val="600"/>
-              </a:spcAft>
-              <a:buSzPct val="100000"/>
-              <a:buChar char="•"/>
-            </a:pPr>
-            <a:r>
-              <a:rPr lang="en-US" sz="1300" dirty="0">
-                <a:solidFill>
-                  <a:srgbClr val="15243A"/>
-                </a:solidFill>
-                <a:latin typeface="Arial" pitchFamily="34" charset="0"/>
-                <a:ea typeface="Arial" pitchFamily="34" charset="-122"/>
-                <a:cs typeface="Arial" pitchFamily="34" charset="-120"/>
-              </a:rPr>
-              <a:t>Join Facebook seller groups</a:t>
-            </a:r>
-            <a:endParaRPr lang="en-US" sz="1300" dirty="0"/>
-          </a:p>
-          <a:p>
-            <a:pPr algn="l" marL="177800" indent="-177800">
-              <a:spcAft>
-                <a:spcPts val="600"/>
-              </a:spcAft>
-              <a:buSzPct val="100000"/>
-              <a:buChar char="•"/>
-            </a:pPr>
-            <a:r>
-              <a:rPr lang="en-US" sz="1300" dirty="0">
-                <a:solidFill>
-                  <a:srgbClr val="15243A"/>
-                </a:solidFill>
-                <a:latin typeface="Arial" pitchFamily="34" charset="0"/>
-                <a:ea typeface="Arial" pitchFamily="34" charset="-122"/>
-                <a:cs typeface="Arial" pitchFamily="34" charset="-120"/>
-              </a:rPr>
-              <a:t>UniPreneur introductions</a:t>
-            </a:r>
-            <a:endParaRPr lang="en-US" sz="1300" dirty="0"/>
-          </a:p>
-        </p:txBody>
-      </p:sp>
-      <p:sp>
-        <p:nvSpPr>
-          <p:cNvPr id="10" name="Text 7"/>
-          <p:cNvSpPr txBox="1"/>
-          <p:nvPr/>
-        </p:nvSpPr>
-        <p:spPr>
-          <a:xfrm>
-            <a:off x="746608" y="4142232"/>
-            <a:ext cx="2834640" cy="402336"/>
+            <a:off x="769468" y="4251960"/>
+            <a:ext cx="2788920" cy="402336"/>
           </a:xfrm>
           <a:prstGeom prst="roundRect">
             <a:avLst>
@@ -1227,7 +1096,7 @@
               <a:buNone/>
             </a:pPr>
             <a:r>
-              <a:rPr lang="en-US" sz="1200" b="1" dirty="0">
+              <a:rPr lang="en-US" sz="1250" b="1" dirty="0">
                 <a:solidFill>
                   <a:srgbClr val="0F766E"/>
                 </a:solidFill>
@@ -1237,28 +1106,28 @@
               </a:rPr>
               <a:t>Goal: 10 pilot shops</a:t>
             </a:r>
-            <a:endParaRPr lang="en-US" sz="1200" dirty="0"/>
+            <a:endParaRPr lang="en-US" sz="1250" dirty="0"/>
           </a:p>
         </p:txBody>
       </p:sp>
       <p:pic>
         <p:nvPicPr>
-          <p:cNvPr id="11" name="Image 1" descr="preencoded.png">    </p:cNvPr>
+          <p:cNvPr id="8" name="Image 0" descr="preencoded.png">    </p:cNvPr>
           <p:cNvPicPr>
             <a:picLocks noChangeAspect="1"/>
           </p:cNvPicPr>
           <p:nvPr/>
         </p:nvPicPr>
         <p:blipFill>
-          <a:blip r:embed="rId2"/>
+          <a:blip r:embed="rId1"/>
           <a:stretch>
             <a:fillRect/>
           </a:stretch>
         </p:blipFill>
         <p:spPr>
           <a:xfrm>
-            <a:off x="3947008" y="2994660"/>
-            <a:ext cx="365760" cy="365760"/>
+            <a:off x="3974440" y="2953512"/>
+            <a:ext cx="310896" cy="310896"/>
           </a:xfrm>
           <a:prstGeom prst="rect">
             <a:avLst/>
@@ -1267,18 +1136,18 @@
       </p:pic>
       <p:sp>
         <p:nvSpPr>
-          <p:cNvPr id="12" name="Shape 8"/>
+          <p:cNvPr id="9" name="Shape 6"/>
           <p:cNvSpPr/>
           <p:nvPr/>
         </p:nvSpPr>
         <p:spPr>
           <a:xfrm>
-            <a:off x="4404208" y="1554480"/>
-            <a:ext cx="3383280" cy="3246120"/>
+            <a:off x="4381348" y="1234440"/>
+            <a:ext cx="3429000" cy="3749040"/>
           </a:xfrm>
           <a:prstGeom prst="roundRect">
             <a:avLst>
-              <a:gd name="adj" fmla="val 5634"/>
+              <a:gd name="adj" fmla="val 5333"/>
             </a:avLst>
           </a:prstGeom>
           <a:solidFill>
@@ -1293,7 +1162,7 @@
           <a:effectLst>
             <a:outerShdw sx="100000" sy="100000" kx="0" ky="0" algn="bl" rotWithShape="0" blurRad="101600" dist="38100" dir="5400000">
               <a:srgbClr val="1A2A4A">
-                <a:alpha val="12000"/>
+                <a:alpha val="14000"/>
               </a:srgbClr>
             </a:outerShdw>
           </a:effectLst>
@@ -1301,60 +1170,14 @@
       </p:sp>
       <p:sp>
         <p:nvSpPr>
-          <p:cNvPr id="13" name="Shape 9"/>
-          <p:cNvSpPr/>
-          <p:nvPr/>
-        </p:nvSpPr>
-        <p:spPr>
-          <a:xfrm>
-            <a:off x="4678528" y="1828800"/>
-            <a:ext cx="658368" cy="658368"/>
-          </a:xfrm>
-          <a:prstGeom prst="roundRect">
-            <a:avLst>
-              <a:gd name="adj" fmla="val 22222"/>
-            </a:avLst>
-          </a:prstGeom>
-          <a:solidFill>
-            <a:srgbClr val="2463E8"/>
-          </a:solidFill>
-          <a:ln/>
-        </p:spPr>
-      </p:sp>
-      <p:pic>
-        <p:nvPicPr>
-          <p:cNvPr id="14" name="Image 2" descr="preencoded.png">    </p:cNvPr>
-          <p:cNvPicPr>
-            <a:picLocks noChangeAspect="1"/>
-          </p:cNvPicPr>
-          <p:nvPr/>
-        </p:nvPicPr>
-        <p:blipFill>
-          <a:blip r:embed="rId3"/>
-          <a:stretch>
-            <a:fillRect/>
-          </a:stretch>
-        </p:blipFill>
-        <p:spPr>
-          <a:xfrm>
-            <a:off x="4824832" y="1975104"/>
-            <a:ext cx="365760" cy="365760"/>
-          </a:xfrm>
-          <a:prstGeom prst="rect">
-            <a:avLst/>
-          </a:prstGeom>
-        </p:spPr>
-      </p:pic>
-      <p:sp>
-        <p:nvSpPr>
-          <p:cNvPr id="15" name="Text 10"/>
+          <p:cNvPr id="10" name="Text 7"/>
           <p:cNvSpPr txBox="1"/>
           <p:nvPr/>
         </p:nvSpPr>
         <p:spPr>
           <a:xfrm>
-            <a:off x="5501488" y="1828800"/>
-            <a:ext cx="2057400" cy="274320"/>
+            <a:off x="4655668" y="1463040"/>
+            <a:ext cx="914400" cy="365760"/>
           </a:xfrm>
           <a:prstGeom prst="rect">
             <a:avLst/>
@@ -1370,7 +1193,46 @@
               <a:buNone/>
             </a:pPr>
             <a:r>
-              <a:rPr lang="en-US" sz="1050" b="1" spc="100" kern="0" dirty="0">
+              <a:rPr lang="en-US" sz="1400" b="1" spc="200" kern="0" dirty="0">
+                <a:solidFill>
+                  <a:srgbClr val="52637A"/>
+                </a:solidFill>
+                <a:latin typeface="Arial" pitchFamily="34" charset="0"/>
+                <a:ea typeface="Arial" pitchFamily="34" charset="-122"/>
+                <a:cs typeface="Arial" pitchFamily="34" charset="-120"/>
+              </a:rPr>
+              <a:t>02</a:t>
+            </a:r>
+            <a:endParaRPr lang="en-US" sz="1400" dirty="0"/>
+          </a:p>
+        </p:txBody>
+      </p:sp>
+      <p:sp>
+        <p:nvSpPr>
+          <p:cNvPr id="11" name="Text 8"/>
+          <p:cNvSpPr txBox="1"/>
+          <p:nvPr/>
+        </p:nvSpPr>
+        <p:spPr>
+          <a:xfrm>
+            <a:off x="5707228" y="1463040"/>
+            <a:ext cx="1828800" cy="365760"/>
+          </a:xfrm>
+          <a:prstGeom prst="rect">
+            <a:avLst/>
+          </a:prstGeom>
+          <a:noFill/>
+          <a:ln/>
+        </p:spPr>
+        <p:txBody>
+          <a:bodyPr wrap="square" lIns="0" tIns="0" rIns="0" bIns="0" rtlCol="0" anchor="ctr"/>
+          <a:lstStyle/>
+          <a:p>
+            <a:pPr algn="r" indent="0" marL="0">
+              <a:buNone/>
+            </a:pPr>
+            <a:r>
+              <a:rPr lang="en-US" sz="1100" b="1" spc="100" kern="0" dirty="0">
                 <a:solidFill>
                   <a:srgbClr val="2463E8"/>
                 </a:solidFill>
@@ -1378,22 +1240,22 @@
                 <a:ea typeface="Arial" pitchFamily="34" charset="-122"/>
                 <a:cs typeface="Arial" pitchFamily="34" charset="-120"/>
               </a:rPr>
-              <a:t>2027 · PUBLIC LAUNCH</a:t>
-            </a:r>
-            <a:endParaRPr lang="en-US" sz="1050" dirty="0"/>
+              <a:t>2027</a:t>
+            </a:r>
+            <a:endParaRPr lang="en-US" sz="1100" dirty="0"/>
           </a:p>
         </p:txBody>
       </p:sp>
       <p:sp>
         <p:nvSpPr>
-          <p:cNvPr id="16" name="Text 11"/>
+          <p:cNvPr id="12" name="Text 9"/>
           <p:cNvSpPr txBox="1"/>
           <p:nvPr/>
         </p:nvSpPr>
         <p:spPr>
           <a:xfrm>
-            <a:off x="5501488" y="2084832"/>
-            <a:ext cx="2103120" cy="457200"/>
+            <a:off x="4564228" y="3611880"/>
+            <a:ext cx="3063240" cy="457200"/>
           </a:xfrm>
           <a:prstGeom prst="rect">
             <a:avLst/>
@@ -1405,11 +1267,11 @@
           <a:bodyPr wrap="square" lIns="0" tIns="0" rIns="0" bIns="0" rtlCol="0" anchor="ctr"/>
           <a:lstStyle/>
           <a:p>
-            <a:pPr algn="l" indent="0" marL="0">
+            <a:pPr algn="ctr" indent="0" marL="0">
               <a:buNone/>
             </a:pPr>
             <a:r>
-              <a:rPr lang="en-US" sz="1700" b="1" dirty="0">
+              <a:rPr lang="en-US" sz="2000" b="1" dirty="0">
                 <a:solidFill>
                   <a:srgbClr val="15243A"/>
                 </a:solidFill>
@@ -1417,86 +1279,22 @@
                 <a:ea typeface="Arial" pitchFamily="34" charset="-122"/>
                 <a:cs typeface="Arial" pitchFamily="34" charset="-120"/>
               </a:rPr>
-              <a:t>2. Merchants bring their buyers</a:t>
-            </a:r>
-            <a:endParaRPr lang="en-US" sz="1700" dirty="0"/>
+              <a:t>Shops bring customers</a:t>
+            </a:r>
+            <a:endParaRPr lang="en-US" sz="2000" dirty="0"/>
           </a:p>
         </p:txBody>
       </p:sp>
       <p:sp>
         <p:nvSpPr>
-          <p:cNvPr id="17" name="Text 12"/>
+          <p:cNvPr id="13" name="Text 10"/>
           <p:cNvSpPr txBox="1"/>
           <p:nvPr/>
         </p:nvSpPr>
         <p:spPr>
           <a:xfrm>
-            <a:off x="4678528" y="2697480"/>
-            <a:ext cx="2880360" cy="1371600"/>
-          </a:xfrm>
-          <a:prstGeom prst="rect">
-            <a:avLst/>
-          </a:prstGeom>
-          <a:noFill/>
-          <a:ln/>
-        </p:spPr>
-        <p:txBody>
-          <a:bodyPr wrap="square" lIns="0" tIns="0" rIns="0" bIns="0" rtlCol="0" anchor="t"/>
-          <a:lstStyle/>
-          <a:p>
-            <a:pPr algn="l" marL="177800" indent="-177800">
-              <a:spcAft>
-                <a:spcPts val="600"/>
-              </a:spcAft>
-              <a:buSzPct val="100000"/>
-              <a:buChar char="•"/>
-            </a:pPr>
-            <a:r>
-              <a:rPr lang="en-US" sz="1300" dirty="0">
-                <a:solidFill>
-                  <a:srgbClr val="15243A"/>
-                </a:solidFill>
-                <a:latin typeface="Arial" pitchFamily="34" charset="0"/>
-                <a:ea typeface="Arial" pitchFamily="34" charset="-122"/>
-                <a:cs typeface="Arial" pitchFamily="34" charset="-120"/>
-              </a:rPr>
-              <a:t>Each shop shares its Rentify link on Facebook and Telegram</a:t>
-            </a:r>
-            <a:endParaRPr lang="en-US" sz="1300" dirty="0"/>
-          </a:p>
-          <a:p>
-            <a:pPr algn="l" marL="177800" indent="-177800">
-              <a:spcAft>
-                <a:spcPts val="600"/>
-              </a:spcAft>
-              <a:buSzPct val="100000"/>
-              <a:buChar char="•"/>
-            </a:pPr>
-            <a:r>
-              <a:rPr lang="en-US" sz="1300" dirty="0">
-                <a:solidFill>
-                  <a:srgbClr val="15243A"/>
-                </a:solidFill>
-                <a:latin typeface="Arial" pitchFamily="34" charset="0"/>
-                <a:ea typeface="Arial" pitchFamily="34" charset="-122"/>
-                <a:cs typeface="Arial" pitchFamily="34" charset="-120"/>
-              </a:rPr>
-              <a:t>Its regular customers order through it</a:t>
-            </a:r>
-            <a:endParaRPr lang="en-US" sz="1300" dirty="0"/>
-          </a:p>
-        </p:txBody>
-      </p:sp>
-      <p:sp>
-        <p:nvSpPr>
-          <p:cNvPr id="18" name="Text 13"/>
-          <p:cNvSpPr txBox="1"/>
-          <p:nvPr/>
-        </p:nvSpPr>
-        <p:spPr>
-          <a:xfrm>
-            <a:off x="4678528" y="4142232"/>
-            <a:ext cx="2834640" cy="402336"/>
+            <a:off x="4701388" y="4251960"/>
+            <a:ext cx="2788920" cy="402336"/>
           </a:xfrm>
           <a:prstGeom prst="roundRect">
             <a:avLst>
@@ -1516,7 +1314,7 @@
               <a:buNone/>
             </a:pPr>
             <a:r>
-              <a:rPr lang="en-US" sz="1200" b="1" dirty="0">
+              <a:rPr lang="en-US" sz="1250" b="1" dirty="0">
                 <a:solidFill>
                   <a:srgbClr val="16A34A"/>
                 </a:solidFill>
@@ -1524,30 +1322,30 @@
                 <a:ea typeface="Arial" pitchFamily="34" charset="-122"/>
                 <a:cs typeface="Arial" pitchFamily="34" charset="-120"/>
               </a:rPr>
-              <a:t>0% commission on their own sales</a:t>
-            </a:r>
-            <a:endParaRPr lang="en-US" sz="1200" dirty="0"/>
+              <a:t>0% on their own sales</a:t>
+            </a:r>
+            <a:endParaRPr lang="en-US" sz="1250" dirty="0"/>
           </a:p>
         </p:txBody>
       </p:sp>
       <p:pic>
         <p:nvPicPr>
-          <p:cNvPr id="19" name="Image 3" descr="preencoded.png">    </p:cNvPr>
+          <p:cNvPr id="14" name="Image 1" descr="preencoded.png">    </p:cNvPr>
           <p:cNvPicPr>
             <a:picLocks noChangeAspect="1"/>
           </p:cNvPicPr>
           <p:nvPr/>
         </p:nvPicPr>
         <p:blipFill>
-          <a:blip r:embed="rId4"/>
+          <a:blip r:embed="rId2"/>
           <a:stretch>
             <a:fillRect/>
           </a:stretch>
         </p:blipFill>
         <p:spPr>
           <a:xfrm>
-            <a:off x="7878928" y="2994660"/>
-            <a:ext cx="365760" cy="365760"/>
+            <a:off x="7906360" y="2953512"/>
+            <a:ext cx="310896" cy="310896"/>
           </a:xfrm>
           <a:prstGeom prst="rect">
             <a:avLst/>
@@ -1556,18 +1354,18 @@
       </p:pic>
       <p:sp>
         <p:nvSpPr>
-          <p:cNvPr id="20" name="Shape 14"/>
+          <p:cNvPr id="15" name="Shape 11"/>
           <p:cNvSpPr/>
           <p:nvPr/>
         </p:nvSpPr>
         <p:spPr>
           <a:xfrm>
-            <a:off x="8336128" y="1554480"/>
-            <a:ext cx="3383280" cy="3246120"/>
+            <a:off x="8313268" y="1234440"/>
+            <a:ext cx="3429000" cy="3749040"/>
           </a:xfrm>
           <a:prstGeom prst="roundRect">
             <a:avLst>
-              <a:gd name="adj" fmla="val 5634"/>
+              <a:gd name="adj" fmla="val 5333"/>
             </a:avLst>
           </a:prstGeom>
           <a:solidFill>
@@ -1582,7 +1380,7 @@
           <a:effectLst>
             <a:outerShdw sx="100000" sy="100000" kx="0" ky="0" algn="bl" rotWithShape="0" blurRad="101600" dist="38100" dir="5400000">
               <a:srgbClr val="1A2A4A">
-                <a:alpha val="12000"/>
+                <a:alpha val="14000"/>
               </a:srgbClr>
             </a:outerShdw>
           </a:effectLst>
@@ -1590,29 +1388,522 @@
       </p:sp>
       <p:sp>
         <p:nvSpPr>
-          <p:cNvPr id="21" name="Shape 15"/>
-          <p:cNvSpPr/>
-          <p:nvPr/>
-        </p:nvSpPr>
-        <p:spPr>
-          <a:xfrm>
-            <a:off x="8610448" y="1828800"/>
-            <a:ext cx="658368" cy="658368"/>
+          <p:cNvPr id="16" name="Text 12"/>
+          <p:cNvSpPr txBox="1"/>
+          <p:nvPr/>
+        </p:nvSpPr>
+        <p:spPr>
+          <a:xfrm>
+            <a:off x="8587588" y="1463040"/>
+            <a:ext cx="914400" cy="365760"/>
+          </a:xfrm>
+          <a:prstGeom prst="rect">
+            <a:avLst/>
+          </a:prstGeom>
+          <a:noFill/>
+          <a:ln/>
+        </p:spPr>
+        <p:txBody>
+          <a:bodyPr wrap="square" lIns="0" tIns="0" rIns="0" bIns="0" rtlCol="0" anchor="ctr"/>
+          <a:lstStyle/>
+          <a:p>
+            <a:pPr algn="l" indent="0" marL="0">
+              <a:buNone/>
+            </a:pPr>
+            <a:r>
+              <a:rPr lang="en-US" sz="1400" b="1" spc="200" kern="0" dirty="0">
+                <a:solidFill>
+                  <a:srgbClr val="52637A"/>
+                </a:solidFill>
+                <a:latin typeface="Arial" pitchFamily="34" charset="0"/>
+                <a:ea typeface="Arial" pitchFamily="34" charset="-122"/>
+                <a:cs typeface="Arial" pitchFamily="34" charset="-120"/>
+              </a:rPr>
+              <a:t>03</a:t>
+            </a:r>
+            <a:endParaRPr lang="en-US" sz="1400" dirty="0"/>
+          </a:p>
+        </p:txBody>
+      </p:sp>
+      <p:sp>
+        <p:nvSpPr>
+          <p:cNvPr id="17" name="Text 13"/>
+          <p:cNvSpPr txBox="1"/>
+          <p:nvPr/>
+        </p:nvSpPr>
+        <p:spPr>
+          <a:xfrm>
+            <a:off x="9639148" y="1463040"/>
+            <a:ext cx="1828800" cy="365760"/>
+          </a:xfrm>
+          <a:prstGeom prst="rect">
+            <a:avLst/>
+          </a:prstGeom>
+          <a:noFill/>
+          <a:ln/>
+        </p:spPr>
+        <p:txBody>
+          <a:bodyPr wrap="square" lIns="0" tIns="0" rIns="0" bIns="0" rtlCol="0" anchor="ctr"/>
+          <a:lstStyle/>
+          <a:p>
+            <a:pPr algn="r" indent="0" marL="0">
+              <a:buNone/>
+            </a:pPr>
+            <a:r>
+              <a:rPr lang="en-US" sz="1100" b="1" spc="100" kern="0" dirty="0">
+                <a:solidFill>
+                  <a:srgbClr val="F97316"/>
+                </a:solidFill>
+                <a:latin typeface="Arial" pitchFamily="34" charset="0"/>
+                <a:ea typeface="Arial" pitchFamily="34" charset="-122"/>
+                <a:cs typeface="Arial" pitchFamily="34" charset="-120"/>
+              </a:rPr>
+              <a:t>2027+</a:t>
+            </a:r>
+            <a:endParaRPr lang="en-US" sz="1100" dirty="0"/>
+          </a:p>
+        </p:txBody>
+      </p:sp>
+      <p:sp>
+        <p:nvSpPr>
+          <p:cNvPr id="18" name="Text 14"/>
+          <p:cNvSpPr txBox="1"/>
+          <p:nvPr/>
+        </p:nvSpPr>
+        <p:spPr>
+          <a:xfrm>
+            <a:off x="8496148" y="3611880"/>
+            <a:ext cx="3063240" cy="457200"/>
+          </a:xfrm>
+          <a:prstGeom prst="rect">
+            <a:avLst/>
+          </a:prstGeom>
+          <a:noFill/>
+          <a:ln/>
+        </p:spPr>
+        <p:txBody>
+          <a:bodyPr wrap="square" lIns="0" tIns="0" rIns="0" bIns="0" rtlCol="0" anchor="ctr"/>
+          <a:lstStyle/>
+          <a:p>
+            <a:pPr algn="ctr" indent="0" marL="0">
+              <a:buNone/>
+            </a:pPr>
+            <a:r>
+              <a:rPr lang="en-US" sz="2000" b="1" dirty="0">
+                <a:solidFill>
+                  <a:srgbClr val="15243A"/>
+                </a:solidFill>
+                <a:latin typeface="Arial" pitchFamily="34" charset="0"/>
+                <a:ea typeface="Arial" pitchFamily="34" charset="-122"/>
+                <a:cs typeface="Arial" pitchFamily="34" charset="-120"/>
+              </a:rPr>
+              <a:t>Buyers find more shops</a:t>
+            </a:r>
+            <a:endParaRPr lang="en-US" sz="2000" dirty="0"/>
+          </a:p>
+        </p:txBody>
+      </p:sp>
+      <p:sp>
+        <p:nvSpPr>
+          <p:cNvPr id="19" name="Text 15"/>
+          <p:cNvSpPr txBox="1"/>
+          <p:nvPr/>
+        </p:nvSpPr>
+        <p:spPr>
+          <a:xfrm>
+            <a:off x="8633308" y="4251960"/>
+            <a:ext cx="2788920" cy="402336"/>
           </a:xfrm>
           <a:prstGeom prst="roundRect">
             <a:avLst>
-              <a:gd name="adj" fmla="val 22222"/>
+              <a:gd name="adj" fmla="val 50000"/>
             </a:avLst>
           </a:prstGeom>
           <a:solidFill>
-            <a:srgbClr val="F97316"/>
+            <a:srgbClr val="FFEDD5"/>
+          </a:solidFill>
+          <a:ln/>
+        </p:spPr>
+        <p:txBody>
+          <a:bodyPr wrap="square" lIns="0" tIns="0" rIns="0" bIns="0" rtlCol="0" anchor="ctr"/>
+          <a:lstStyle/>
+          <a:p>
+            <a:pPr algn="ctr" indent="0" marL="0">
+              <a:buNone/>
+            </a:pPr>
+            <a:r>
+              <a:rPr lang="en-US" sz="1250" b="1" dirty="0">
+                <a:solidFill>
+                  <a:srgbClr val="C2410C"/>
+                </a:solidFill>
+                <a:latin typeface="Arial" pitchFamily="34" charset="0"/>
+                <a:ea typeface="Arial" pitchFamily="34" charset="-122"/>
+                <a:cs typeface="Arial" pitchFamily="34" charset="-120"/>
+              </a:rPr>
+              <a:t>Commission on marketplace sales</a:t>
+            </a:r>
+            <a:endParaRPr lang="en-US" sz="1250" dirty="0"/>
+          </a:p>
+        </p:txBody>
+      </p:sp>
+      <p:sp>
+        <p:nvSpPr>
+          <p:cNvPr id="20" name="Shape 16"/>
+          <p:cNvSpPr/>
+          <p:nvPr/>
+        </p:nvSpPr>
+        <p:spPr>
+          <a:xfrm>
+            <a:off x="860908" y="1965960"/>
+            <a:ext cx="457200" cy="457200"/>
+          </a:xfrm>
+          <a:prstGeom prst="ellipse">
+            <a:avLst/>
+          </a:prstGeom>
+          <a:solidFill>
+            <a:srgbClr val="0AA7A2"/>
           </a:solidFill>
           <a:ln/>
         </p:spPr>
       </p:sp>
       <p:pic>
         <p:nvPicPr>
-          <p:cNvPr id="22" name="Image 4" descr="preencoded.png">    </p:cNvPr>
+          <p:cNvPr id="21" name="Image 2" descr="preencoded.png">    </p:cNvPr>
+          <p:cNvPicPr>
+            <a:picLocks noChangeAspect="1"/>
+          </p:cNvPicPr>
+          <p:nvPr/>
+        </p:nvPicPr>
+        <p:blipFill>
+          <a:blip r:embed="rId3"/>
+          <a:stretch>
+            <a:fillRect/>
+          </a:stretch>
+        </p:blipFill>
+        <p:spPr>
+          <a:xfrm>
+            <a:off x="975208" y="2080260"/>
+            <a:ext cx="228600" cy="228600"/>
+          </a:xfrm>
+          <a:prstGeom prst="rect">
+            <a:avLst/>
+          </a:prstGeom>
+        </p:spPr>
+      </p:pic>
+      <p:sp>
+        <p:nvSpPr>
+          <p:cNvPr id="22" name="Text 17"/>
+          <p:cNvSpPr txBox="1"/>
+          <p:nvPr/>
+        </p:nvSpPr>
+        <p:spPr>
+          <a:xfrm>
+            <a:off x="586588" y="2450592"/>
+            <a:ext cx="1005840" cy="237744"/>
+          </a:xfrm>
+          <a:prstGeom prst="rect">
+            <a:avLst/>
+          </a:prstGeom>
+          <a:noFill/>
+          <a:ln/>
+        </p:spPr>
+        <p:txBody>
+          <a:bodyPr wrap="square" lIns="0" tIns="0" rIns="0" bIns="0" rtlCol="0" anchor="ctr"/>
+          <a:lstStyle/>
+          <a:p>
+            <a:pPr algn="ctr" indent="0" marL="0">
+              <a:buNone/>
+            </a:pPr>
+            <a:r>
+              <a:rPr lang="en-US" sz="1050" b="1" dirty="0">
+                <a:solidFill>
+                  <a:srgbClr val="64748B"/>
+                </a:solidFill>
+                <a:latin typeface="Arial" pitchFamily="34" charset="0"/>
+                <a:ea typeface="Arial" pitchFamily="34" charset="-122"/>
+                <a:cs typeface="Arial" pitchFamily="34" charset="-120"/>
+              </a:rPr>
+              <a:t>Markets</a:t>
+            </a:r>
+            <a:endParaRPr lang="en-US" sz="1050" dirty="0"/>
+          </a:p>
+        </p:txBody>
+      </p:sp>
+      <p:sp>
+        <p:nvSpPr>
+          <p:cNvPr id="23" name="Shape 18"/>
+          <p:cNvSpPr/>
+          <p:nvPr/>
+        </p:nvSpPr>
+        <p:spPr>
+          <a:xfrm>
+            <a:off x="1089508" y="2715768"/>
+            <a:ext cx="1074420" cy="182880"/>
+          </a:xfrm>
+          <a:prstGeom prst="line">
+            <a:avLst/>
+          </a:prstGeom>
+          <a:noFill/>
+          <a:ln w="19050">
+            <a:solidFill>
+              <a:srgbClr val="E2E8F0"/>
+            </a:solidFill>
+            <a:prstDash val="solid"/>
+          </a:ln>
+        </p:spPr>
+      </p:sp>
+      <p:sp>
+        <p:nvSpPr>
+          <p:cNvPr id="24" name="Shape 19"/>
+          <p:cNvSpPr/>
+          <p:nvPr/>
+        </p:nvSpPr>
+        <p:spPr>
+          <a:xfrm>
+            <a:off x="1866748" y="1965960"/>
+            <a:ext cx="457200" cy="457200"/>
+          </a:xfrm>
+          <a:prstGeom prst="ellipse">
+            <a:avLst/>
+          </a:prstGeom>
+          <a:solidFill>
+            <a:srgbClr val="1877F2"/>
+          </a:solidFill>
+          <a:ln/>
+        </p:spPr>
+      </p:sp>
+      <p:sp>
+        <p:nvSpPr>
+          <p:cNvPr id="25" name="Text 20"/>
+          <p:cNvSpPr txBox="1"/>
+          <p:nvPr/>
+        </p:nvSpPr>
+        <p:spPr>
+          <a:xfrm>
+            <a:off x="1866748" y="1988820"/>
+            <a:ext cx="457200" cy="457200"/>
+          </a:xfrm>
+          <a:prstGeom prst="rect">
+            <a:avLst/>
+          </a:prstGeom>
+          <a:noFill/>
+          <a:ln/>
+        </p:spPr>
+        <p:txBody>
+          <a:bodyPr wrap="square" lIns="0" tIns="0" rIns="0" bIns="0" rtlCol="0" anchor="ctr"/>
+          <a:lstStyle/>
+          <a:p>
+            <a:pPr algn="ctr" indent="0" marL="0">
+              <a:buNone/>
+            </a:pPr>
+            <a:r>
+              <a:rPr lang="en-US" sz="2200" b="1" dirty="0">
+                <a:solidFill>
+                  <a:srgbClr val="FFFFFF"/>
+                </a:solidFill>
+                <a:latin typeface="Arial" pitchFamily="34" charset="0"/>
+                <a:ea typeface="Arial" pitchFamily="34" charset="-122"/>
+                <a:cs typeface="Arial" pitchFamily="34" charset="-120"/>
+              </a:rPr>
+              <a:t>f</a:t>
+            </a:r>
+            <a:endParaRPr lang="en-US" sz="2200" dirty="0"/>
+          </a:p>
+        </p:txBody>
+      </p:sp>
+      <p:sp>
+        <p:nvSpPr>
+          <p:cNvPr id="26" name="Text 21"/>
+          <p:cNvSpPr txBox="1"/>
+          <p:nvPr/>
+        </p:nvSpPr>
+        <p:spPr>
+          <a:xfrm>
+            <a:off x="1592428" y="2450592"/>
+            <a:ext cx="1005840" cy="237744"/>
+          </a:xfrm>
+          <a:prstGeom prst="rect">
+            <a:avLst/>
+          </a:prstGeom>
+          <a:noFill/>
+          <a:ln/>
+        </p:spPr>
+        <p:txBody>
+          <a:bodyPr wrap="square" lIns="0" tIns="0" rIns="0" bIns="0" rtlCol="0" anchor="ctr"/>
+          <a:lstStyle/>
+          <a:p>
+            <a:pPr algn="ctr" indent="0" marL="0">
+              <a:buNone/>
+            </a:pPr>
+            <a:r>
+              <a:rPr lang="en-US" sz="1050" b="1" dirty="0">
+                <a:solidFill>
+                  <a:srgbClr val="64748B"/>
+                </a:solidFill>
+                <a:latin typeface="Arial" pitchFamily="34" charset="0"/>
+                <a:ea typeface="Arial" pitchFamily="34" charset="-122"/>
+                <a:cs typeface="Arial" pitchFamily="34" charset="-120"/>
+              </a:rPr>
+              <a:t>FB groups</a:t>
+            </a:r>
+            <a:endParaRPr lang="en-US" sz="1050" dirty="0"/>
+          </a:p>
+        </p:txBody>
+      </p:sp>
+      <p:sp>
+        <p:nvSpPr>
+          <p:cNvPr id="27" name="Shape 22"/>
+          <p:cNvSpPr/>
+          <p:nvPr/>
+        </p:nvSpPr>
+        <p:spPr>
+          <a:xfrm>
+            <a:off x="2095348" y="2715768"/>
+            <a:ext cx="68580" cy="182880"/>
+          </a:xfrm>
+          <a:prstGeom prst="line">
+            <a:avLst/>
+          </a:prstGeom>
+          <a:noFill/>
+          <a:ln w="19050">
+            <a:solidFill>
+              <a:srgbClr val="E2E8F0"/>
+            </a:solidFill>
+            <a:prstDash val="solid"/>
+          </a:ln>
+        </p:spPr>
+      </p:sp>
+      <p:sp>
+        <p:nvSpPr>
+          <p:cNvPr id="28" name="Shape 23"/>
+          <p:cNvSpPr/>
+          <p:nvPr/>
+        </p:nvSpPr>
+        <p:spPr>
+          <a:xfrm>
+            <a:off x="2872588" y="1965960"/>
+            <a:ext cx="457200" cy="457200"/>
+          </a:xfrm>
+          <a:prstGeom prst="ellipse">
+            <a:avLst/>
+          </a:prstGeom>
+          <a:solidFill>
+            <a:srgbClr val="4F46E5"/>
+          </a:solidFill>
+          <a:ln/>
+        </p:spPr>
+      </p:sp>
+      <p:pic>
+        <p:nvPicPr>
+          <p:cNvPr id="29" name="Image 3" descr="preencoded.png">    </p:cNvPr>
+          <p:cNvPicPr>
+            <a:picLocks noChangeAspect="1"/>
+          </p:cNvPicPr>
+          <p:nvPr/>
+        </p:nvPicPr>
+        <p:blipFill>
+          <a:blip r:embed="rId4"/>
+          <a:stretch>
+            <a:fillRect/>
+          </a:stretch>
+        </p:blipFill>
+        <p:spPr>
+          <a:xfrm>
+            <a:off x="2986888" y="2080260"/>
+            <a:ext cx="228600" cy="228600"/>
+          </a:xfrm>
+          <a:prstGeom prst="rect">
+            <a:avLst/>
+          </a:prstGeom>
+        </p:spPr>
+      </p:pic>
+      <p:sp>
+        <p:nvSpPr>
+          <p:cNvPr id="30" name="Text 24"/>
+          <p:cNvSpPr txBox="1"/>
+          <p:nvPr/>
+        </p:nvSpPr>
+        <p:spPr>
+          <a:xfrm>
+            <a:off x="2598268" y="2450592"/>
+            <a:ext cx="1005840" cy="237744"/>
+          </a:xfrm>
+          <a:prstGeom prst="rect">
+            <a:avLst/>
+          </a:prstGeom>
+          <a:noFill/>
+          <a:ln/>
+        </p:spPr>
+        <p:txBody>
+          <a:bodyPr wrap="square" lIns="0" tIns="0" rIns="0" bIns="0" rtlCol="0" anchor="ctr"/>
+          <a:lstStyle/>
+          <a:p>
+            <a:pPr algn="ctr" indent="0" marL="0">
+              <a:buNone/>
+            </a:pPr>
+            <a:r>
+              <a:rPr lang="en-US" sz="1050" b="1" dirty="0">
+                <a:solidFill>
+                  <a:srgbClr val="64748B"/>
+                </a:solidFill>
+                <a:latin typeface="Arial" pitchFamily="34" charset="0"/>
+                <a:ea typeface="Arial" pitchFamily="34" charset="-122"/>
+                <a:cs typeface="Arial" pitchFamily="34" charset="-120"/>
+              </a:rPr>
+              <a:t>UniPreneur</a:t>
+            </a:r>
+            <a:endParaRPr lang="en-US" sz="1050" dirty="0"/>
+          </a:p>
+        </p:txBody>
+      </p:sp>
+      <p:sp>
+        <p:nvSpPr>
+          <p:cNvPr id="31" name="Shape 25"/>
+          <p:cNvSpPr/>
+          <p:nvPr/>
+        </p:nvSpPr>
+        <p:spPr>
+          <a:xfrm flipH="1">
+            <a:off x="2163928" y="2715768"/>
+            <a:ext cx="937260" cy="182880"/>
+          </a:xfrm>
+          <a:prstGeom prst="line">
+            <a:avLst/>
+          </a:prstGeom>
+          <a:noFill/>
+          <a:ln w="19050">
+            <a:solidFill>
+              <a:srgbClr val="E2E8F0"/>
+            </a:solidFill>
+            <a:prstDash val="solid"/>
+          </a:ln>
+        </p:spPr>
+      </p:sp>
+      <p:sp>
+        <p:nvSpPr>
+          <p:cNvPr id="32" name="Shape 26"/>
+          <p:cNvSpPr/>
+          <p:nvPr/>
+        </p:nvSpPr>
+        <p:spPr>
+          <a:xfrm>
+            <a:off x="1834744" y="2907792"/>
+            <a:ext cx="658368" cy="658368"/>
+          </a:xfrm>
+          <a:prstGeom prst="roundRect">
+            <a:avLst>
+              <a:gd name="adj" fmla="val 22000"/>
+            </a:avLst>
+          </a:prstGeom>
+          <a:solidFill>
+            <a:srgbClr val="0AA7A2"/>
+          </a:solidFill>
+          <a:ln/>
+        </p:spPr>
+      </p:sp>
+      <p:pic>
+        <p:nvPicPr>
+          <p:cNvPr id="33" name="Image 4" descr="preencoded.png">    </p:cNvPr>
           <p:cNvPicPr>
             <a:picLocks noChangeAspect="1"/>
           </p:cNvPicPr>
@@ -1626,8 +1917,8 @@
         </p:blipFill>
         <p:spPr>
           <a:xfrm>
-            <a:off x="8756752" y="1975104"/>
-            <a:ext cx="365760" cy="365760"/>
+            <a:off x="1999336" y="3072384"/>
+            <a:ext cx="329184" cy="329184"/>
           </a:xfrm>
           <a:prstGeom prst="rect">
             <a:avLst/>
@@ -1636,235 +1927,74 @@
       </p:pic>
       <p:sp>
         <p:nvSpPr>
-          <p:cNvPr id="23" name="Text 16"/>
+          <p:cNvPr id="34" name="Text 27"/>
           <p:cNvSpPr txBox="1"/>
           <p:nvPr/>
         </p:nvSpPr>
         <p:spPr>
           <a:xfrm>
-            <a:off x="9433408" y="1828800"/>
-            <a:ext cx="2057400" cy="274320"/>
-          </a:xfrm>
-          <a:prstGeom prst="rect">
-            <a:avLst/>
-          </a:prstGeom>
-          <a:noFill/>
-          <a:ln/>
+            <a:off x="2328520" y="2752344"/>
+            <a:ext cx="420624" cy="420624"/>
+          </a:xfrm>
+          <a:prstGeom prst="ellipse">
+            <a:avLst/>
+          </a:prstGeom>
+          <a:solidFill>
+            <a:srgbClr val="FFFFFF"/>
+          </a:solidFill>
+          <a:ln w="25400">
+            <a:solidFill>
+              <a:srgbClr val="0AA7A2"/>
+            </a:solidFill>
+          </a:ln>
         </p:spPr>
         <p:txBody>
           <a:bodyPr wrap="square" lIns="0" tIns="0" rIns="0" bIns="0" rtlCol="0" anchor="ctr"/>
           <a:lstStyle/>
           <a:p>
-            <a:pPr algn="l" indent="0" marL="0">
+            <a:pPr algn="ctr" indent="0" marL="0">
               <a:buNone/>
             </a:pPr>
             <a:r>
-              <a:rPr lang="en-US" sz="1050" b="1" spc="100" kern="0" dirty="0">
+              <a:rPr lang="en-US" sz="1200" b="1" dirty="0">
                 <a:solidFill>
-                  <a:srgbClr val="F97316"/>
+                  <a:srgbClr val="0AA7A2"/>
                 </a:solidFill>
                 <a:latin typeface="Arial" pitchFamily="34" charset="0"/>
                 <a:ea typeface="Arial" pitchFamily="34" charset="-122"/>
                 <a:cs typeface="Arial" pitchFamily="34" charset="-120"/>
               </a:rPr>
-              <a:t>2027 ONWARDS</a:t>
-            </a:r>
-            <a:endParaRPr lang="en-US" sz="1050" dirty="0"/>
+              <a:t>10</a:t>
+            </a:r>
+            <a:endParaRPr lang="en-US" sz="1200" dirty="0"/>
           </a:p>
         </p:txBody>
       </p:sp>
       <p:sp>
         <p:nvSpPr>
-          <p:cNvPr id="24" name="Text 17"/>
-          <p:cNvSpPr txBox="1"/>
-          <p:nvPr/>
-        </p:nvSpPr>
-        <p:spPr>
-          <a:xfrm>
-            <a:off x="9433408" y="2084832"/>
-            <a:ext cx="2103120" cy="457200"/>
-          </a:xfrm>
-          <a:prstGeom prst="rect">
-            <a:avLst/>
-          </a:prstGeom>
-          <a:noFill/>
-          <a:ln/>
-        </p:spPr>
-        <p:txBody>
-          <a:bodyPr wrap="square" lIns="0" tIns="0" rIns="0" bIns="0" rtlCol="0" anchor="ctr"/>
-          <a:lstStyle/>
-          <a:p>
-            <a:pPr algn="l" indent="0" marL="0">
-              <a:buNone/>
-            </a:pPr>
-            <a:r>
-              <a:rPr lang="en-US" sz="1700" b="1" dirty="0">
-                <a:solidFill>
-                  <a:srgbClr val="15243A"/>
-                </a:solidFill>
-                <a:latin typeface="Arial" pitchFamily="34" charset="0"/>
-                <a:ea typeface="Arial" pitchFamily="34" charset="-122"/>
-                <a:cs typeface="Arial" pitchFamily="34" charset="-120"/>
-              </a:rPr>
-              <a:t>3. Buyers discover more shops</a:t>
-            </a:r>
-            <a:endParaRPr lang="en-US" sz="1700" dirty="0"/>
-          </a:p>
-        </p:txBody>
-      </p:sp>
-      <p:sp>
-        <p:nvSpPr>
-          <p:cNvPr id="25" name="Text 18"/>
-          <p:cNvSpPr txBox="1"/>
-          <p:nvPr/>
-        </p:nvSpPr>
-        <p:spPr>
-          <a:xfrm>
-            <a:off x="8610448" y="2697480"/>
-            <a:ext cx="2880360" cy="1371600"/>
-          </a:xfrm>
-          <a:prstGeom prst="rect">
-            <a:avLst/>
-          </a:prstGeom>
-          <a:noFill/>
-          <a:ln/>
-        </p:spPr>
-        <p:txBody>
-          <a:bodyPr wrap="square" lIns="0" tIns="0" rIns="0" bIns="0" rtlCol="0" anchor="t"/>
-          <a:lstStyle/>
-          <a:p>
-            <a:pPr algn="l" marL="177800" indent="-177800">
-              <a:spcAft>
-                <a:spcPts val="600"/>
-              </a:spcAft>
-              <a:buSzPct val="100000"/>
-              <a:buChar char="•"/>
-            </a:pPr>
-            <a:r>
-              <a:rPr lang="en-US" sz="1300" dirty="0">
-                <a:solidFill>
-                  <a:srgbClr val="15243A"/>
-                </a:solidFill>
-                <a:latin typeface="Arial" pitchFamily="34" charset="0"/>
-                <a:ea typeface="Arial" pitchFamily="34" charset="-122"/>
-                <a:cs typeface="Arial" pitchFamily="34" charset="-120"/>
-              </a:rPr>
-              <a:t>The marketplace shows products from every shop</a:t>
-            </a:r>
-            <a:endParaRPr lang="en-US" sz="1300" dirty="0"/>
-          </a:p>
-          <a:p>
-            <a:pPr algn="l" marL="177800" indent="-177800">
-              <a:spcAft>
-                <a:spcPts val="600"/>
-              </a:spcAft>
-              <a:buSzPct val="100000"/>
-              <a:buChar char="•"/>
-            </a:pPr>
-            <a:r>
-              <a:rPr lang="en-US" sz="1300" dirty="0">
-                <a:solidFill>
-                  <a:srgbClr val="15243A"/>
-                </a:solidFill>
-                <a:latin typeface="Arial" pitchFamily="34" charset="0"/>
-                <a:ea typeface="Arial" pitchFamily="34" charset="-122"/>
-                <a:cs typeface="Arial" pitchFamily="34" charset="-120"/>
-              </a:rPr>
-              <a:t>Festival and category campaigns</a:t>
-            </a:r>
-            <a:endParaRPr lang="en-US" sz="1300" dirty="0"/>
-          </a:p>
-          <a:p>
-            <a:pPr algn="l" marL="177800" indent="-177800">
-              <a:spcAft>
-                <a:spcPts val="600"/>
-              </a:spcAft>
-              <a:buSzPct val="100000"/>
-              <a:buChar char="•"/>
-            </a:pPr>
-            <a:r>
-              <a:rPr lang="en-US" sz="1300" dirty="0">
-                <a:solidFill>
-                  <a:srgbClr val="15243A"/>
-                </a:solidFill>
-                <a:latin typeface="Arial" pitchFamily="34" charset="0"/>
-                <a:ea typeface="Arial" pitchFamily="34" charset="-122"/>
-                <a:cs typeface="Arial" pitchFamily="34" charset="-120"/>
-              </a:rPr>
-              <a:t>SME associations and delivery partners</a:t>
-            </a:r>
-            <a:endParaRPr lang="en-US" sz="1300" dirty="0"/>
-          </a:p>
-        </p:txBody>
-      </p:sp>
-      <p:sp>
-        <p:nvSpPr>
-          <p:cNvPr id="26" name="Text 19"/>
-          <p:cNvSpPr txBox="1"/>
-          <p:nvPr/>
-        </p:nvSpPr>
-        <p:spPr>
-          <a:xfrm>
-            <a:off x="8610448" y="4142232"/>
-            <a:ext cx="2834640" cy="402336"/>
+          <p:cNvPr id="35" name="Shape 28"/>
+          <p:cNvSpPr/>
+          <p:nvPr/>
+        </p:nvSpPr>
+        <p:spPr>
+          <a:xfrm>
+            <a:off x="4701388" y="2331720"/>
+            <a:ext cx="658368" cy="658368"/>
           </a:xfrm>
           <a:prstGeom prst="roundRect">
             <a:avLst>
-              <a:gd name="adj" fmla="val 50000"/>
+              <a:gd name="adj" fmla="val 22000"/>
             </a:avLst>
           </a:prstGeom>
           <a:solidFill>
-            <a:srgbClr val="FFEDD5"/>
-          </a:solidFill>
-          <a:ln/>
-        </p:spPr>
-        <p:txBody>
-          <a:bodyPr wrap="square" lIns="0" tIns="0" rIns="0" bIns="0" rtlCol="0" anchor="ctr"/>
-          <a:lstStyle/>
-          <a:p>
-            <a:pPr algn="ctr" indent="0" marL="0">
-              <a:buNone/>
-            </a:pPr>
-            <a:r>
-              <a:rPr lang="en-US" sz="1200" b="1" dirty="0">
-                <a:solidFill>
-                  <a:srgbClr val="C2410C"/>
-                </a:solidFill>
-                <a:latin typeface="Arial" pitchFamily="34" charset="0"/>
-                <a:ea typeface="Arial" pitchFamily="34" charset="-122"/>
-                <a:cs typeface="Arial" pitchFamily="34" charset="-120"/>
-              </a:rPr>
-              <a:t>Marketplace sales earn commission</a:t>
-            </a:r>
-            <a:endParaRPr lang="en-US" sz="1200" dirty="0"/>
-          </a:p>
-        </p:txBody>
-      </p:sp>
-      <p:sp>
-        <p:nvSpPr>
-          <p:cNvPr id="27" name="Shape 20"/>
-          <p:cNvSpPr/>
-          <p:nvPr/>
-        </p:nvSpPr>
-        <p:spPr>
-          <a:xfrm>
-            <a:off x="472288" y="5001768"/>
-            <a:ext cx="11247120" cy="457200"/>
-          </a:xfrm>
-          <a:prstGeom prst="roundRect">
-            <a:avLst>
-              <a:gd name="adj" fmla="val 50000"/>
-            </a:avLst>
-          </a:prstGeom>
-          <a:solidFill>
-            <a:srgbClr val="EEF2FF"/>
+            <a:srgbClr val="0AA7A2"/>
           </a:solidFill>
           <a:ln/>
         </p:spPr>
       </p:sp>
       <p:pic>
         <p:nvPicPr>
-          <p:cNvPr id="28" name="Image 5" descr="preencoded.png">    </p:cNvPr>
+          <p:cNvPr id="36" name="Image 5" descr="preencoded.png">    </p:cNvPr>
           <p:cNvPicPr>
             <a:picLocks noChangeAspect="1"/>
           </p:cNvPicPr>
@@ -1878,7 +2008,31 @@
         </p:blipFill>
         <p:spPr>
           <a:xfrm>
-            <a:off x="700888" y="5102352"/>
+            <a:off x="4865980" y="2496312"/>
+            <a:ext cx="329184" cy="329184"/>
+          </a:xfrm>
+          <a:prstGeom prst="rect">
+            <a:avLst/>
+          </a:prstGeom>
+        </p:spPr>
+      </p:pic>
+      <p:pic>
+        <p:nvPicPr>
+          <p:cNvPr id="37" name="Image 6" descr="preencoded.png">    </p:cNvPr>
+          <p:cNvPicPr>
+            <a:picLocks noChangeAspect="1"/>
+          </p:cNvPicPr>
+          <p:nvPr/>
+        </p:nvPicPr>
+        <p:blipFill>
+          <a:blip r:embed="rId7"/>
+          <a:stretch>
+            <a:fillRect/>
+          </a:stretch>
+        </p:blipFill>
+        <p:spPr>
+          <a:xfrm>
+            <a:off x="5405476" y="2532888"/>
             <a:ext cx="256032" cy="256032"/>
           </a:xfrm>
           <a:prstGeom prst="rect">
@@ -1888,14 +2042,34 @@
       </p:pic>
       <p:sp>
         <p:nvSpPr>
-          <p:cNvPr id="29" name="Text 21"/>
+          <p:cNvPr id="38" name="Shape 29"/>
+          <p:cNvSpPr/>
+          <p:nvPr/>
+        </p:nvSpPr>
+        <p:spPr>
+          <a:xfrm>
+            <a:off x="5707228" y="2221992"/>
+            <a:ext cx="402336" cy="402336"/>
+          </a:xfrm>
+          <a:prstGeom prst="ellipse">
+            <a:avLst/>
+          </a:prstGeom>
+          <a:solidFill>
+            <a:srgbClr val="1877F2"/>
+          </a:solidFill>
+          <a:ln/>
+        </p:spPr>
+      </p:sp>
+      <p:sp>
+        <p:nvSpPr>
+          <p:cNvPr id="39" name="Text 30"/>
           <p:cNvSpPr txBox="1"/>
           <p:nvPr/>
         </p:nvSpPr>
         <p:spPr>
           <a:xfrm>
-            <a:off x="1066648" y="5001768"/>
-            <a:ext cx="10424160" cy="457200"/>
+            <a:off x="5707228" y="2242109"/>
+            <a:ext cx="402336" cy="402336"/>
           </a:xfrm>
           <a:prstGeom prst="rect">
             <a:avLst/>
@@ -1907,11 +2081,685 @@
           <a:bodyPr wrap="square" lIns="0" tIns="0" rIns="0" bIns="0" rtlCol="0" anchor="ctr"/>
           <a:lstStyle/>
           <a:p>
-            <a:pPr algn="l" indent="0" marL="0">
+            <a:pPr algn="ctr" indent="0" marL="0">
               <a:buNone/>
             </a:pPr>
             <a:r>
-              <a:rPr lang="en-US" sz="1300" b="1" dirty="0">
+              <a:rPr lang="en-US" sz="1900" b="1" dirty="0">
+                <a:solidFill>
+                  <a:srgbClr val="FFFFFF"/>
+                </a:solidFill>
+                <a:latin typeface="Arial" pitchFamily="34" charset="0"/>
+                <a:ea typeface="Arial" pitchFamily="34" charset="-122"/>
+                <a:cs typeface="Arial" pitchFamily="34" charset="-120"/>
+              </a:rPr>
+              <a:t>f</a:t>
+            </a:r>
+            <a:endParaRPr lang="en-US" sz="1900" dirty="0"/>
+          </a:p>
+        </p:txBody>
+      </p:sp>
+      <p:sp>
+        <p:nvSpPr>
+          <p:cNvPr id="40" name="Shape 31"/>
+          <p:cNvSpPr/>
+          <p:nvPr/>
+        </p:nvSpPr>
+        <p:spPr>
+          <a:xfrm>
+            <a:off x="5707228" y="2697480"/>
+            <a:ext cx="402336" cy="402336"/>
+          </a:xfrm>
+          <a:prstGeom prst="ellipse">
+            <a:avLst/>
+          </a:prstGeom>
+          <a:solidFill>
+            <a:srgbClr val="27A7E7"/>
+          </a:solidFill>
+          <a:ln/>
+        </p:spPr>
+      </p:sp>
+      <p:pic>
+        <p:nvPicPr>
+          <p:cNvPr id="41" name="Image 7" descr="preencoded.png">    </p:cNvPr>
+          <p:cNvPicPr>
+            <a:picLocks noChangeAspect="1"/>
+          </p:cNvPicPr>
+          <p:nvPr/>
+        </p:nvPicPr>
+        <p:blipFill>
+          <a:blip r:embed="rId8"/>
+          <a:stretch>
+            <a:fillRect/>
+          </a:stretch>
+        </p:blipFill>
+        <p:spPr>
+          <a:xfrm>
+            <a:off x="5807812" y="2798064"/>
+            <a:ext cx="201168" cy="201168"/>
+          </a:xfrm>
+          <a:prstGeom prst="rect">
+            <a:avLst/>
+          </a:prstGeom>
+        </p:spPr>
+      </p:pic>
+      <p:pic>
+        <p:nvPicPr>
+          <p:cNvPr id="42" name="Image 8" descr="preencoded.png">    </p:cNvPr>
+          <p:cNvPicPr>
+            <a:picLocks noChangeAspect="1"/>
+          </p:cNvPicPr>
+          <p:nvPr/>
+        </p:nvPicPr>
+        <p:blipFill>
+          <a:blip r:embed="rId9"/>
+          <a:stretch>
+            <a:fillRect/>
+          </a:stretch>
+        </p:blipFill>
+        <p:spPr>
+          <a:xfrm>
+            <a:off x="6182716" y="2532888"/>
+            <a:ext cx="256032" cy="256032"/>
+          </a:xfrm>
+          <a:prstGeom prst="rect">
+            <a:avLst/>
+          </a:prstGeom>
+        </p:spPr>
+      </p:pic>
+      <p:sp>
+        <p:nvSpPr>
+          <p:cNvPr id="43" name="Shape 32"/>
+          <p:cNvSpPr/>
+          <p:nvPr/>
+        </p:nvSpPr>
+        <p:spPr>
+          <a:xfrm>
+            <a:off x="6502756" y="2331720"/>
+            <a:ext cx="658368" cy="658368"/>
+          </a:xfrm>
+          <a:prstGeom prst="roundRect">
+            <a:avLst>
+              <a:gd name="adj" fmla="val 22000"/>
+            </a:avLst>
+          </a:prstGeom>
+          <a:solidFill>
+            <a:srgbClr val="2463E8"/>
+          </a:solidFill>
+          <a:ln/>
+        </p:spPr>
+      </p:sp>
+      <p:pic>
+        <p:nvPicPr>
+          <p:cNvPr id="44" name="Image 9" descr="preencoded.png">    </p:cNvPr>
+          <p:cNvPicPr>
+            <a:picLocks noChangeAspect="1"/>
+          </p:cNvPicPr>
+          <p:nvPr/>
+        </p:nvPicPr>
+        <p:blipFill>
+          <a:blip r:embed="rId10"/>
+          <a:stretch>
+            <a:fillRect/>
+          </a:stretch>
+        </p:blipFill>
+        <p:spPr>
+          <a:xfrm>
+            <a:off x="6667348" y="2496312"/>
+            <a:ext cx="329184" cy="329184"/>
+          </a:xfrm>
+          <a:prstGeom prst="rect">
+            <a:avLst/>
+          </a:prstGeom>
+        </p:spPr>
+      </p:pic>
+      <p:sp>
+        <p:nvSpPr>
+          <p:cNvPr id="45" name="Text 33"/>
+          <p:cNvSpPr txBox="1"/>
+          <p:nvPr/>
+        </p:nvSpPr>
+        <p:spPr>
+          <a:xfrm>
+            <a:off x="5478628" y="3154680"/>
+            <a:ext cx="914400" cy="237744"/>
+          </a:xfrm>
+          <a:prstGeom prst="rect">
+            <a:avLst/>
+          </a:prstGeom>
+          <a:noFill/>
+          <a:ln/>
+        </p:spPr>
+        <p:txBody>
+          <a:bodyPr wrap="square" lIns="0" tIns="0" rIns="0" bIns="0" rtlCol="0" anchor="ctr"/>
+          <a:lstStyle/>
+          <a:p>
+            <a:pPr algn="ctr" indent="0" marL="0">
+              <a:buNone/>
+            </a:pPr>
+            <a:r>
+              <a:rPr lang="en-US" sz="1050" b="1" dirty="0">
+                <a:solidFill>
+                  <a:srgbClr val="64748B"/>
+                </a:solidFill>
+                <a:latin typeface="Arial" pitchFamily="34" charset="0"/>
+                <a:ea typeface="Arial" pitchFamily="34" charset="-122"/>
+                <a:cs typeface="Arial" pitchFamily="34" charset="-120"/>
+              </a:rPr>
+              <a:t>Store link</a:t>
+            </a:r>
+            <a:endParaRPr lang="en-US" sz="1050" dirty="0"/>
+          </a:p>
+        </p:txBody>
+      </p:sp>
+      <p:sp>
+        <p:nvSpPr>
+          <p:cNvPr id="46" name="Text 34"/>
+          <p:cNvSpPr txBox="1"/>
+          <p:nvPr/>
+        </p:nvSpPr>
+        <p:spPr>
+          <a:xfrm>
+            <a:off x="6319876" y="3154680"/>
+            <a:ext cx="1024128" cy="237744"/>
+          </a:xfrm>
+          <a:prstGeom prst="rect">
+            <a:avLst/>
+          </a:prstGeom>
+          <a:noFill/>
+          <a:ln/>
+        </p:spPr>
+        <p:txBody>
+          <a:bodyPr wrap="square" lIns="0" tIns="0" rIns="0" bIns="0" rtlCol="0" anchor="ctr"/>
+          <a:lstStyle/>
+          <a:p>
+            <a:pPr algn="ctr" indent="0" marL="0">
+              <a:buNone/>
+            </a:pPr>
+            <a:r>
+              <a:rPr lang="en-US" sz="1050" b="1" dirty="0">
+                <a:solidFill>
+                  <a:srgbClr val="2463E8"/>
+                </a:solidFill>
+                <a:latin typeface="Arial" pitchFamily="34" charset="0"/>
+                <a:ea typeface="Arial" pitchFamily="34" charset="-122"/>
+                <a:cs typeface="Arial" pitchFamily="34" charset="-120"/>
+              </a:rPr>
+              <a:t>Customers</a:t>
+            </a:r>
+            <a:endParaRPr lang="en-US" sz="1050" dirty="0"/>
+          </a:p>
+        </p:txBody>
+      </p:sp>
+      <p:sp>
+        <p:nvSpPr>
+          <p:cNvPr id="47" name="Shape 35"/>
+          <p:cNvSpPr/>
+          <p:nvPr/>
+        </p:nvSpPr>
+        <p:spPr>
+          <a:xfrm>
+            <a:off x="9662008" y="1920240"/>
+            <a:ext cx="731520" cy="731520"/>
+          </a:xfrm>
+          <a:prstGeom prst="roundRect">
+            <a:avLst>
+              <a:gd name="adj" fmla="val 22000"/>
+            </a:avLst>
+          </a:prstGeom>
+          <a:solidFill>
+            <a:srgbClr val="F97316"/>
+          </a:solidFill>
+          <a:ln/>
+        </p:spPr>
+      </p:sp>
+      <p:pic>
+        <p:nvPicPr>
+          <p:cNvPr id="48" name="Image 10" descr="preencoded.png">    </p:cNvPr>
+          <p:cNvPicPr>
+            <a:picLocks noChangeAspect="1"/>
+          </p:cNvPicPr>
+          <p:nvPr/>
+        </p:nvPicPr>
+        <p:blipFill>
+          <a:blip r:embed="rId11"/>
+          <a:stretch>
+            <a:fillRect/>
+          </a:stretch>
+        </p:blipFill>
+        <p:spPr>
+          <a:xfrm>
+            <a:off x="9844888" y="2103120"/>
+            <a:ext cx="365760" cy="365760"/>
+          </a:xfrm>
+          <a:prstGeom prst="rect">
+            <a:avLst/>
+          </a:prstGeom>
+        </p:spPr>
+      </p:pic>
+      <p:sp>
+        <p:nvSpPr>
+          <p:cNvPr id="49" name="Shape 36"/>
+          <p:cNvSpPr/>
+          <p:nvPr/>
+        </p:nvSpPr>
+        <p:spPr>
+          <a:xfrm>
+            <a:off x="9044788" y="2651760"/>
+            <a:ext cx="982980" cy="274320"/>
+          </a:xfrm>
+          <a:prstGeom prst="line">
+            <a:avLst/>
+          </a:prstGeom>
+          <a:noFill/>
+          <a:ln w="19050">
+            <a:solidFill>
+              <a:srgbClr val="FED7AA"/>
+            </a:solidFill>
+            <a:prstDash val="solid"/>
+          </a:ln>
+        </p:spPr>
+      </p:sp>
+      <p:sp>
+        <p:nvSpPr>
+          <p:cNvPr id="50" name="Shape 37"/>
+          <p:cNvSpPr/>
+          <p:nvPr/>
+        </p:nvSpPr>
+        <p:spPr>
+          <a:xfrm>
+            <a:off x="8816188" y="2926080"/>
+            <a:ext cx="457200" cy="457200"/>
+          </a:xfrm>
+          <a:prstGeom prst="roundRect">
+            <a:avLst>
+              <a:gd name="adj" fmla="val 22000"/>
+            </a:avLst>
+          </a:prstGeom>
+          <a:solidFill>
+            <a:srgbClr val="CBD5E1"/>
+          </a:solidFill>
+          <a:ln/>
+        </p:spPr>
+      </p:sp>
+      <p:pic>
+        <p:nvPicPr>
+          <p:cNvPr id="51" name="Image 11" descr="preencoded.png">    </p:cNvPr>
+          <p:cNvPicPr>
+            <a:picLocks noChangeAspect="1"/>
+          </p:cNvPicPr>
+          <p:nvPr/>
+        </p:nvPicPr>
+        <p:blipFill>
+          <a:blip r:embed="rId12"/>
+          <a:stretch>
+            <a:fillRect/>
+          </a:stretch>
+        </p:blipFill>
+        <p:spPr>
+          <a:xfrm>
+            <a:off x="8930488" y="3040380"/>
+            <a:ext cx="228600" cy="228600"/>
+          </a:xfrm>
+          <a:prstGeom prst="rect">
+            <a:avLst/>
+          </a:prstGeom>
+        </p:spPr>
+      </p:pic>
+      <p:sp>
+        <p:nvSpPr>
+          <p:cNvPr id="52" name="Shape 38"/>
+          <p:cNvSpPr/>
+          <p:nvPr/>
+        </p:nvSpPr>
+        <p:spPr>
+          <a:xfrm>
+            <a:off x="9703156" y="2651760"/>
+            <a:ext cx="324612" cy="274320"/>
+          </a:xfrm>
+          <a:prstGeom prst="line">
+            <a:avLst/>
+          </a:prstGeom>
+          <a:noFill/>
+          <a:ln w="19050">
+            <a:solidFill>
+              <a:srgbClr val="FED7AA"/>
+            </a:solidFill>
+            <a:prstDash val="solid"/>
+          </a:ln>
+        </p:spPr>
+      </p:sp>
+      <p:sp>
+        <p:nvSpPr>
+          <p:cNvPr id="53" name="Shape 39"/>
+          <p:cNvSpPr/>
+          <p:nvPr/>
+        </p:nvSpPr>
+        <p:spPr>
+          <a:xfrm>
+            <a:off x="9474556" y="2926080"/>
+            <a:ext cx="457200" cy="457200"/>
+          </a:xfrm>
+          <a:prstGeom prst="roundRect">
+            <a:avLst>
+              <a:gd name="adj" fmla="val 22000"/>
+            </a:avLst>
+          </a:prstGeom>
+          <a:solidFill>
+            <a:srgbClr val="0AA7A2"/>
+          </a:solidFill>
+          <a:ln/>
+        </p:spPr>
+      </p:sp>
+      <p:pic>
+        <p:nvPicPr>
+          <p:cNvPr id="54" name="Image 12" descr="preencoded.png">    </p:cNvPr>
+          <p:cNvPicPr>
+            <a:picLocks noChangeAspect="1"/>
+          </p:cNvPicPr>
+          <p:nvPr/>
+        </p:nvPicPr>
+        <p:blipFill>
+          <a:blip r:embed="rId13"/>
+          <a:stretch>
+            <a:fillRect/>
+          </a:stretch>
+        </p:blipFill>
+        <p:spPr>
+          <a:xfrm>
+            <a:off x="9588856" y="3040380"/>
+            <a:ext cx="228600" cy="228600"/>
+          </a:xfrm>
+          <a:prstGeom prst="rect">
+            <a:avLst/>
+          </a:prstGeom>
+        </p:spPr>
+      </p:pic>
+      <p:sp>
+        <p:nvSpPr>
+          <p:cNvPr id="55" name="Shape 40"/>
+          <p:cNvSpPr/>
+          <p:nvPr/>
+        </p:nvSpPr>
+        <p:spPr>
+          <a:xfrm flipH="1">
+            <a:off x="10027768" y="2651760"/>
+            <a:ext cx="333756" cy="274320"/>
+          </a:xfrm>
+          <a:prstGeom prst="line">
+            <a:avLst/>
+          </a:prstGeom>
+          <a:noFill/>
+          <a:ln w="19050">
+            <a:solidFill>
+              <a:srgbClr val="FED7AA"/>
+            </a:solidFill>
+            <a:prstDash val="solid"/>
+          </a:ln>
+        </p:spPr>
+      </p:sp>
+      <p:sp>
+        <p:nvSpPr>
+          <p:cNvPr id="56" name="Shape 41"/>
+          <p:cNvSpPr/>
+          <p:nvPr/>
+        </p:nvSpPr>
+        <p:spPr>
+          <a:xfrm>
+            <a:off x="10132924" y="2926080"/>
+            <a:ext cx="457200" cy="457200"/>
+          </a:xfrm>
+          <a:prstGeom prst="roundRect">
+            <a:avLst>
+              <a:gd name="adj" fmla="val 22000"/>
+            </a:avLst>
+          </a:prstGeom>
+          <a:solidFill>
+            <a:srgbClr val="CBD5E1"/>
+          </a:solidFill>
+          <a:ln/>
+        </p:spPr>
+      </p:sp>
+      <p:pic>
+        <p:nvPicPr>
+          <p:cNvPr id="57" name="Image 13" descr="preencoded.png">    </p:cNvPr>
+          <p:cNvPicPr>
+            <a:picLocks noChangeAspect="1"/>
+          </p:cNvPicPr>
+          <p:nvPr/>
+        </p:nvPicPr>
+        <p:blipFill>
+          <a:blip r:embed="rId14"/>
+          <a:stretch>
+            <a:fillRect/>
+          </a:stretch>
+        </p:blipFill>
+        <p:spPr>
+          <a:xfrm>
+            <a:off x="10247224" y="3040380"/>
+            <a:ext cx="228600" cy="228600"/>
+          </a:xfrm>
+          <a:prstGeom prst="rect">
+            <a:avLst/>
+          </a:prstGeom>
+        </p:spPr>
+      </p:pic>
+      <p:sp>
+        <p:nvSpPr>
+          <p:cNvPr id="58" name="Shape 42"/>
+          <p:cNvSpPr/>
+          <p:nvPr/>
+        </p:nvSpPr>
+        <p:spPr>
+          <a:xfrm flipH="1">
+            <a:off x="10027768" y="2651760"/>
+            <a:ext cx="992124" cy="274320"/>
+          </a:xfrm>
+          <a:prstGeom prst="line">
+            <a:avLst/>
+          </a:prstGeom>
+          <a:noFill/>
+          <a:ln w="19050">
+            <a:solidFill>
+              <a:srgbClr val="FED7AA"/>
+            </a:solidFill>
+            <a:prstDash val="solid"/>
+          </a:ln>
+        </p:spPr>
+      </p:sp>
+      <p:sp>
+        <p:nvSpPr>
+          <p:cNvPr id="59" name="Shape 43"/>
+          <p:cNvSpPr/>
+          <p:nvPr/>
+        </p:nvSpPr>
+        <p:spPr>
+          <a:xfrm>
+            <a:off x="10791292" y="2926080"/>
+            <a:ext cx="457200" cy="457200"/>
+          </a:xfrm>
+          <a:prstGeom prst="roundRect">
+            <a:avLst>
+              <a:gd name="adj" fmla="val 22000"/>
+            </a:avLst>
+          </a:prstGeom>
+          <a:solidFill>
+            <a:srgbClr val="CBD5E1"/>
+          </a:solidFill>
+          <a:ln/>
+        </p:spPr>
+      </p:sp>
+      <p:pic>
+        <p:nvPicPr>
+          <p:cNvPr id="60" name="Image 14" descr="preencoded.png">    </p:cNvPr>
+          <p:cNvPicPr>
+            <a:picLocks noChangeAspect="1"/>
+          </p:cNvPicPr>
+          <p:nvPr/>
+        </p:nvPicPr>
+        <p:blipFill>
+          <a:blip r:embed="rId15"/>
+          <a:stretch>
+            <a:fillRect/>
+          </a:stretch>
+        </p:blipFill>
+        <p:spPr>
+          <a:xfrm>
+            <a:off x="10905592" y="3040380"/>
+            <a:ext cx="228600" cy="228600"/>
+          </a:xfrm>
+          <a:prstGeom prst="rect">
+            <a:avLst/>
+          </a:prstGeom>
+        </p:spPr>
+      </p:pic>
+      <p:sp>
+        <p:nvSpPr>
+          <p:cNvPr id="61" name="Shape 44"/>
+          <p:cNvSpPr/>
+          <p:nvPr/>
+        </p:nvSpPr>
+        <p:spPr>
+          <a:xfrm>
+            <a:off x="10027768" y="4983480"/>
+            <a:ext cx="914" cy="320040"/>
+          </a:xfrm>
+          <a:prstGeom prst="line">
+            <a:avLst/>
+          </a:prstGeom>
+          <a:noFill/>
+          <a:ln w="25400">
+            <a:solidFill>
+              <a:srgbClr val="4F46E5"/>
+            </a:solidFill>
+            <a:prstDash val="dash"/>
+          </a:ln>
+        </p:spPr>
+      </p:sp>
+      <p:sp>
+        <p:nvSpPr>
+          <p:cNvPr id="62" name="Shape 45"/>
+          <p:cNvSpPr/>
+          <p:nvPr/>
+        </p:nvSpPr>
+        <p:spPr>
+          <a:xfrm>
+            <a:off x="2163928" y="5303520"/>
+            <a:ext cx="7863840" cy="914"/>
+          </a:xfrm>
+          <a:prstGeom prst="line">
+            <a:avLst/>
+          </a:prstGeom>
+          <a:noFill/>
+          <a:ln w="25400">
+            <a:solidFill>
+              <a:srgbClr val="4F46E5"/>
+            </a:solidFill>
+            <a:prstDash val="dash"/>
+          </a:ln>
+        </p:spPr>
+      </p:sp>
+      <p:sp>
+        <p:nvSpPr>
+          <p:cNvPr id="63" name="Shape 46"/>
+          <p:cNvSpPr/>
+          <p:nvPr/>
+        </p:nvSpPr>
+        <p:spPr>
+          <a:xfrm flipV="1">
+            <a:off x="2163928" y="5010912"/>
+            <a:ext cx="914" cy="292608"/>
+          </a:xfrm>
+          <a:prstGeom prst="line">
+            <a:avLst/>
+          </a:prstGeom>
+          <a:noFill/>
+          <a:ln w="25400">
+            <a:solidFill>
+              <a:srgbClr val="4F46E5"/>
+            </a:solidFill>
+            <a:prstDash val="dash"/>
+            <a:tailEnd type="triangle"/>
+          </a:ln>
+        </p:spPr>
+      </p:sp>
+      <p:sp>
+        <p:nvSpPr>
+          <p:cNvPr id="64" name="Shape 47"/>
+          <p:cNvSpPr/>
+          <p:nvPr/>
+        </p:nvSpPr>
+        <p:spPr>
+          <a:xfrm>
+            <a:off x="4449928" y="5102352"/>
+            <a:ext cx="3291840" cy="402336"/>
+          </a:xfrm>
+          <a:prstGeom prst="roundRect">
+            <a:avLst>
+              <a:gd name="adj" fmla="val 50000"/>
+            </a:avLst>
+          </a:prstGeom>
+          <a:solidFill>
+            <a:srgbClr val="EEF2FF"/>
+          </a:solidFill>
+          <a:ln w="12700">
+            <a:solidFill>
+              <a:srgbClr val="4F46E5"/>
+            </a:solidFill>
+            <a:prstDash val="solid"/>
+          </a:ln>
+        </p:spPr>
+      </p:sp>
+      <p:pic>
+        <p:nvPicPr>
+          <p:cNvPr id="65" name="Image 15" descr="preencoded.png">    </p:cNvPr>
+          <p:cNvPicPr>
+            <a:picLocks noChangeAspect="1"/>
+          </p:cNvPicPr>
+          <p:nvPr/>
+        </p:nvPicPr>
+        <p:blipFill>
+          <a:blip r:embed="rId16"/>
+          <a:stretch>
+            <a:fillRect/>
+          </a:stretch>
+        </p:blipFill>
+        <p:spPr>
+          <a:xfrm>
+            <a:off x="4632808" y="5193792"/>
+            <a:ext cx="219456" cy="219456"/>
+          </a:xfrm>
+          <a:prstGeom prst="rect">
+            <a:avLst/>
+          </a:prstGeom>
+        </p:spPr>
+      </p:pic>
+      <p:sp>
+        <p:nvSpPr>
+          <p:cNvPr id="66" name="Text 48"/>
+          <p:cNvSpPr txBox="1"/>
+          <p:nvPr/>
+        </p:nvSpPr>
+        <p:spPr>
+          <a:xfrm>
+            <a:off x="4907128" y="5102352"/>
+            <a:ext cx="2697480" cy="402336"/>
+          </a:xfrm>
+          <a:prstGeom prst="rect">
+            <a:avLst/>
+          </a:prstGeom>
+          <a:noFill/>
+          <a:ln/>
+        </p:spPr>
+        <p:txBody>
+          <a:bodyPr wrap="square" lIns="0" tIns="0" rIns="0" bIns="0" rtlCol="0" anchor="ctr"/>
+          <a:lstStyle/>
+          <a:p>
+            <a:pPr algn="ctr" indent="0" marL="0">
+              <a:buNone/>
+            </a:pPr>
+            <a:r>
+              <a:rPr lang="en-US" sz="1250" b="1" dirty="0">
                 <a:solidFill>
                   <a:srgbClr val="4F46E5"/>
                 </a:solidFill>
@@ -1919,40 +2767,26 @@
                 <a:ea typeface="Arial" pitchFamily="34" charset="-122"/>
                 <a:cs typeface="Arial" pitchFamily="34" charset="-120"/>
               </a:rPr>
-              <a:t>The loop: </a:t>
-            </a:r>
-            <a:pPr algn="l" indent="0" marL="0">
-              <a:buNone/>
-            </a:pPr>
-            <a:r>
-              <a:rPr lang="en-US" sz="1300" dirty="0">
-                <a:solidFill>
-                  <a:srgbClr val="15243A"/>
-                </a:solidFill>
-                <a:latin typeface="Arial" pitchFamily="34" charset="0"/>
-                <a:ea typeface="Arial" pitchFamily="34" charset="-122"/>
-                <a:cs typeface="Arial" pitchFamily="34" charset="-120"/>
-              </a:rPr>
-              <a:t>more shops bring more buyers, and more buyers attract more shops. Shops also earn referral credit for inviting other shops.</a:t>
-            </a:r>
-            <a:endParaRPr lang="en-US" sz="1300" dirty="0"/>
+              <a:t>More buyers bring more shops</a:t>
+            </a:r>
+            <a:endParaRPr lang="en-US" sz="1250" dirty="0"/>
           </a:p>
         </p:txBody>
       </p:sp>
       <p:sp>
         <p:nvSpPr>
-          <p:cNvPr id="30" name="Shape 22"/>
+          <p:cNvPr id="67" name="Shape 49"/>
           <p:cNvSpPr/>
           <p:nvPr/>
         </p:nvSpPr>
         <p:spPr>
           <a:xfrm>
-            <a:off x="472288" y="5641848"/>
-            <a:ext cx="11247120" cy="713232"/>
+            <a:off x="449428" y="5669280"/>
+            <a:ext cx="11292840" cy="566928"/>
           </a:xfrm>
           <a:prstGeom prst="roundRect">
             <a:avLst>
-              <a:gd name="adj" fmla="val 23077"/>
+              <a:gd name="adj" fmla="val 25806"/>
             </a:avLst>
           </a:prstGeom>
           <a:solidFill>
@@ -1963,14 +2797,14 @@
       </p:sp>
       <p:sp>
         <p:nvSpPr>
-          <p:cNvPr id="31" name="Text 23"/>
+          <p:cNvPr id="68" name="Text 50"/>
           <p:cNvSpPr txBox="1"/>
           <p:nvPr/>
         </p:nvSpPr>
         <p:spPr>
           <a:xfrm>
-            <a:off x="746608" y="5641848"/>
-            <a:ext cx="1737360" cy="713232"/>
+            <a:off x="723748" y="5669280"/>
+            <a:ext cx="1737360" cy="566928"/>
           </a:xfrm>
           <a:prstGeom prst="rect">
             <a:avLst/>
@@ -2000,16 +2834,40 @@
           </a:p>
         </p:txBody>
       </p:sp>
-      <p:sp>
-        <p:nvSpPr>
-          <p:cNvPr id="32" name="Text 24"/>
+      <p:pic>
+        <p:nvPicPr>
+          <p:cNvPr id="69" name="Image 16" descr="preencoded.png">    </p:cNvPr>
+          <p:cNvPicPr>
+            <a:picLocks noChangeAspect="1"/>
+          </p:cNvPicPr>
+          <p:nvPr/>
+        </p:nvPicPr>
+        <p:blipFill>
+          <a:blip r:embed="rId17"/>
+          <a:stretch>
+            <a:fillRect/>
+          </a:stretch>
+        </p:blipFill>
+        <p:spPr>
+          <a:xfrm>
+            <a:off x="2552548" y="5833872"/>
+            <a:ext cx="237744" cy="237744"/>
+          </a:xfrm>
+          <a:prstGeom prst="rect">
+            <a:avLst/>
+          </a:prstGeom>
+        </p:spPr>
+      </p:pic>
+      <p:sp>
+        <p:nvSpPr>
+          <p:cNvPr id="70" name="Text 51"/>
           <p:cNvSpPr txBox="1"/>
           <p:nvPr/>
         </p:nvSpPr>
         <p:spPr>
           <a:xfrm>
-            <a:off x="2575408" y="5641848"/>
-            <a:ext cx="2956560" cy="713232"/>
+            <a:off x="2918308" y="5669280"/>
+            <a:ext cx="2606040" cy="566928"/>
           </a:xfrm>
           <a:prstGeom prst="rect">
             <a:avLst/>
@@ -2025,7 +2883,7 @@
               <a:buNone/>
             </a:pPr>
             <a:r>
-              <a:rPr lang="en-US" sz="2000" b="1" dirty="0">
+              <a:rPr lang="en-US" sz="1800" b="1" dirty="0">
                 <a:solidFill>
                   <a:srgbClr val="FFFFFF"/>
                 </a:solidFill>
@@ -2041,28 +2899,52 @@
             <a:r>
               <a:rPr lang="en-US" sz="1200" dirty="0">
                 <a:solidFill>
-                  <a:srgbClr val="CBD5E1"/>
+                  <a:srgbClr val="9FB3CF"/>
                 </a:solidFill>
                 <a:latin typeface="Arial" pitchFamily="34" charset="0"/>
                 <a:ea typeface="Arial" pitchFamily="34" charset="-122"/>
                 <a:cs typeface="Arial" pitchFamily="34" charset="-120"/>
               </a:rPr>
-              <a:t>shops active after 30 days</a:t>
+              <a:t>shops stay active</a:t>
             </a:r>
             <a:endParaRPr lang="en-US" sz="1600" dirty="0"/>
           </a:p>
         </p:txBody>
       </p:sp>
-      <p:sp>
-        <p:nvSpPr>
-          <p:cNvPr id="33" name="Text 25"/>
+      <p:pic>
+        <p:nvPicPr>
+          <p:cNvPr id="71" name="Image 17" descr="preencoded.png">    </p:cNvPr>
+          <p:cNvPicPr>
+            <a:picLocks noChangeAspect="1"/>
+          </p:cNvPicPr>
+          <p:nvPr/>
+        </p:nvPicPr>
+        <p:blipFill>
+          <a:blip r:embed="rId18"/>
+          <a:stretch>
+            <a:fillRect/>
+          </a:stretch>
+        </p:blipFill>
+        <p:spPr>
+          <a:xfrm>
+            <a:off x="5615788" y="5833872"/>
+            <a:ext cx="237744" cy="237744"/>
+          </a:xfrm>
+          <a:prstGeom prst="rect">
+            <a:avLst/>
+          </a:prstGeom>
+        </p:spPr>
+      </p:pic>
+      <p:sp>
+        <p:nvSpPr>
+          <p:cNvPr id="72" name="Text 52"/>
           <p:cNvSpPr txBox="1"/>
           <p:nvPr/>
         </p:nvSpPr>
         <p:spPr>
           <a:xfrm>
-            <a:off x="5623408" y="5641848"/>
-            <a:ext cx="2956560" cy="713232"/>
+            <a:off x="5981548" y="5669280"/>
+            <a:ext cx="2606040" cy="566928"/>
           </a:xfrm>
           <a:prstGeom prst="rect">
             <a:avLst/>
@@ -2078,7 +2960,7 @@
               <a:buNone/>
             </a:pPr>
             <a:r>
-              <a:rPr lang="en-US" sz="2000" b="1" dirty="0">
+              <a:rPr lang="en-US" sz="1800" b="1" dirty="0">
                 <a:solidFill>
                   <a:srgbClr val="FFFFFF"/>
                 </a:solidFill>
@@ -2094,7 +2976,7 @@
             <a:r>
               <a:rPr lang="en-US" sz="1200" dirty="0">
                 <a:solidFill>
-                  <a:srgbClr val="CBD5E1"/>
+                  <a:srgbClr val="9FB3CF"/>
                 </a:solidFill>
                 <a:latin typeface="Arial" pitchFamily="34" charset="0"/>
                 <a:ea typeface="Arial" pitchFamily="34" charset="-122"/>
@@ -2106,16 +2988,40 @@
           </a:p>
         </p:txBody>
       </p:sp>
-      <p:sp>
-        <p:nvSpPr>
-          <p:cNvPr id="34" name="Text 26"/>
+      <p:pic>
+        <p:nvPicPr>
+          <p:cNvPr id="73" name="Image 18" descr="preencoded.png">    </p:cNvPr>
+          <p:cNvPicPr>
+            <a:picLocks noChangeAspect="1"/>
+          </p:cNvPicPr>
+          <p:nvPr/>
+        </p:nvPicPr>
+        <p:blipFill>
+          <a:blip r:embed="rId19"/>
+          <a:stretch>
+            <a:fillRect/>
+          </a:stretch>
+        </p:blipFill>
+        <p:spPr>
+          <a:xfrm>
+            <a:off x="8679028" y="5833872"/>
+            <a:ext cx="237744" cy="237744"/>
+          </a:xfrm>
+          <a:prstGeom prst="rect">
+            <a:avLst/>
+          </a:prstGeom>
+        </p:spPr>
+      </p:pic>
+      <p:sp>
+        <p:nvSpPr>
+          <p:cNvPr id="74" name="Text 53"/>
           <p:cNvSpPr txBox="1"/>
           <p:nvPr/>
         </p:nvSpPr>
         <p:spPr>
           <a:xfrm>
-            <a:off x="8671408" y="5641848"/>
-            <a:ext cx="2956560" cy="713232"/>
+            <a:off x="9044788" y="5669280"/>
+            <a:ext cx="2606040" cy="566928"/>
           </a:xfrm>
           <a:prstGeom prst="rect">
             <a:avLst/>
@@ -2131,7 +3037,7 @@
               <a:buNone/>
             </a:pPr>
             <a:r>
-              <a:rPr lang="en-US" sz="2000" b="1" dirty="0">
+              <a:rPr lang="en-US" sz="1800" b="1" dirty="0">
                 <a:solidFill>
                   <a:srgbClr val="FFFFFF"/>
                 </a:solidFill>
@@ -2147,13 +3053,13 @@
             <a:r>
               <a:rPr lang="en-US" sz="1200" dirty="0">
                 <a:solidFill>
-                  <a:srgbClr val="CBD5E1"/>
+                  <a:srgbClr val="9FB3CF"/>
                 </a:solidFill>
                 <a:latin typeface="Arial" pitchFamily="34" charset="0"/>
                 <a:ea typeface="Arial" pitchFamily="34" charset="-122"/>
                 <a:cs typeface="Arial" pitchFamily="34" charset="-120"/>
               </a:rPr>
-              <a:t>will pay a subscription</a:t>
+              <a:t>will pay</a:t>
             </a:r>
             <a:endParaRPr lang="en-US" sz="1600" dirty="0"/>
           </a:p>
@@ -2161,13 +3067,13 @@
       </p:sp>
       <p:sp>
         <p:nvSpPr>
-          <p:cNvPr id="35" name="Text 27"/>
+          <p:cNvPr id="75" name="Text 54"/>
           <p:cNvSpPr txBox="1"/>
           <p:nvPr/>
         </p:nvSpPr>
         <p:spPr>
           <a:xfrm>
-            <a:off x="548640" y="6400800"/>
+            <a:off x="548640" y="6355080"/>
             <a:ext cx="11064240" cy="274320"/>
           </a:xfrm>
           <a:prstGeom prst="rect">
@@ -2180,7 +3086,7 @@
           <a:bodyPr wrap="square" lIns="0" tIns="0" rIns="0" bIns="0" rtlCol="0" anchor="ctr"/>
           <a:lstStyle/>
           <a:p>
-            <a:pPr algn="ctr" indent="0" marL="0">
+            <a:pPr algn="l" indent="0" marL="0">
               <a:buNone/>
             </a:pPr>
             <a:r>
@@ -2192,7 +3098,7 @@
                 <a:ea typeface="Arial" pitchFamily="34" charset="-122"/>
                 <a:cs typeface="Arial" pitchFamily="34" charset="-120"/>
               </a:rPr>
-              <a:t>Proposed targets, agreed before the pilot starts. Marketplace-discovered orders are measured separately from shops’ own customers.</a:t>
+              <a:t>Proposed pilot targets, agreed before the pilot starts. Marketplace-discovered orders are counted separately from shops’ own customers.</a:t>
             </a:r>
             <a:endParaRPr lang="en-US" sz="1000" dirty="0"/>
           </a:p>

</xml_diff>